<commit_message>
Add multi-template catalog export and upload templates to Supabase.
Split PPTX into cover/single/two/three templates, refactor presentation export, and sync default templates to Storage.

Co-authored-by: Cursor <cursoragent@cursor.com>
</commit_message>
<xml_diff>
--- a/public/catalog-template.pptx
+++ b/public/catalog-template.pptx
@@ -11591,7 +11591,7 @@
                 <a:cs typeface="Calibri"/>
                 <a:sym typeface="Calibri"/>
               </a:rPr>
-              <a:t>{{projectName}} {{floorName}}         </a:t>
+              <a:t>{{שם_פרויקט}} {{שם_קומה}}         </a:t>
             </a:r>
             <a:endParaRPr/>
           </a:p>
@@ -11618,7 +11618,7 @@
                 <a:cs typeface="Calibri"/>
                 <a:sym typeface="Calibri"/>
               </a:rPr>
-              <a:t>{{editionLine}}   {{year}}</a:t>
+              <a:t>{{מהדורה}}   {{שנה}}</a:t>
             </a:r>
             <a:endParaRPr/>
           </a:p>
@@ -12319,7 +12319,7 @@
                     </a:extLst>
                   </a:hlinkClick>
                 </a:rPr>
-                <a:t>{{productUrl}}</a:t>
+                <a:t>{{קישור_מוצר}}</a:t>
               </a:r>
               <a:endParaRPr/>
             </a:p>
@@ -12452,7 +12452,7 @@
                           <a:cs typeface="Calibri"/>
                           <a:sym typeface="Calibri"/>
                         </a:rPr>
-                        <a:t>{{reflector}}</a:t>
+                        <a:t>{{רפלקטור}}</a:t>
                       </a:r>
                       <a:endParaRPr sz="1600" u="none" cap="none" strike="noStrike"/>
                     </a:p>
@@ -12596,7 +12596,7 @@
                           <a:cs typeface="Calibri"/>
                           <a:sym typeface="Calibri"/>
                         </a:rPr>
-                        <a:t>{{lensCover}}</a:t>
+                        <a:t>{{עדשה_כיסוי}}</a:t>
                       </a:r>
                       <a:endParaRPr sz="1600" u="none" cap="none" strike="noStrike"/>
                     </a:p>
@@ -12740,7 +12740,7 @@
                           <a:cs typeface="Calibri"/>
                           <a:sym typeface="Calibri"/>
                         </a:rPr>
-                        <a:t>{{beamAngle}}</a:t>
+                        <a:t>{{זווית_הארה}}</a:t>
                       </a:r>
                       <a:endParaRPr sz="1600" u="none" cap="none" strike="noStrike"/>
                     </a:p>
@@ -12884,7 +12884,7 @@
                           <a:cs typeface="Calibri"/>
                           <a:sym typeface="Calibri"/>
                         </a:rPr>
-                        <a:t>{{adjustment}}</a:t>
+                        <a:t>{{כיוונון}}</a:t>
                       </a:r>
                       <a:endParaRPr sz="1600" u="none" cap="none" strike="noStrike"/>
                     </a:p>
@@ -13028,7 +13028,7 @@
                           <a:cs typeface="Calibri"/>
                           <a:sym typeface="Calibri"/>
                         </a:rPr>
-                        <a:t>{{lightDistribution}}</a:t>
+                        <a:t>{{פיזור_אור}}</a:t>
                       </a:r>
                       <a:endParaRPr sz="1600" u="none" cap="none" strike="noStrike"/>
                     </a:p>
@@ -13221,7 +13221,7 @@
                 <a:cs typeface="Calibri"/>
                 <a:sym typeface="Calibri"/>
               </a:rPr>
-              <a:t>{{roomNames}}</a:t>
+              <a:t>{{חדרים}}</a:t>
             </a:r>
             <a:endParaRPr/>
           </a:p>
@@ -13405,7 +13405,7 @@
                           <a:cs typeface="Calibri"/>
                           <a:sym typeface="Calibri"/>
                         </a:rPr>
-                        <a:t>{{lampLife}}</a:t>
+                        <a:t>{{אורך_חיים}}</a:t>
                       </a:r>
                       <a:endParaRPr sz="1600" u="none" cap="none" strike="noStrike"/>
                     </a:p>
@@ -13549,7 +13549,7 @@
                           <a:cs typeface="Calibri"/>
                           <a:sym typeface="Calibri"/>
                         </a:rPr>
-                        <a:t>{{efficiency}}</a:t>
+                        <a:t>{{יעילות}}</a:t>
                       </a:r>
                       <a:endParaRPr sz="1600" u="none" cap="none" strike="noStrike"/>
                     </a:p>
@@ -13693,7 +13693,7 @@
                           <a:cs typeface="Calibri"/>
                           <a:sym typeface="Calibri"/>
                         </a:rPr>
-                        <a:t>{{glare}}</a:t>
+                        <a:t>{{סינוור}}</a:t>
                       </a:r>
                       <a:endParaRPr sz="1600" u="none" cap="none" strike="noStrike"/>
                     </a:p>
@@ -13837,7 +13837,7 @@
                           <a:cs typeface="Calibri"/>
                           <a:sym typeface="Calibri"/>
                         </a:rPr>
-                        <a:t>{{driverLocation}}</a:t>
+                        <a:t>{{מיקום_ציוד_עזר}}</a:t>
                       </a:r>
                       <a:endParaRPr sz="1600" u="none" cap="none" strike="noStrike"/>
                     </a:p>
@@ -13981,7 +13981,7 @@
                           <a:cs typeface="Calibri"/>
                           <a:sym typeface="Calibri"/>
                         </a:rPr>
-                        <a:t>{{dimmingMethod}}</a:t>
+                        <a:t>{{שיטת_שליטה}}</a:t>
                       </a:r>
                       <a:endParaRPr sz="1600" u="none" cap="none" strike="noStrike"/>
                     </a:p>
@@ -14227,7 +14227,7 @@
                           <a:cs typeface="Calibri"/>
                           <a:sym typeface="Calibri"/>
                         </a:rPr>
-                        <a:t>{{finishColor}}</a:t>
+                        <a:t>{{צבע_גמר}}</a:t>
                       </a:r>
                       <a:endParaRPr sz="1600" u="none" cap="none" strike="noStrike"/>
                     </a:p>
@@ -14371,7 +14371,7 @@
                           <a:cs typeface="Calibri"/>
                           <a:sym typeface="Calibri"/>
                         </a:rPr>
-                        <a:t>{{bodyDiameter}}</a:t>
+                        <a:t>{{קוטר_גוף}}</a:t>
                       </a:r>
                       <a:endParaRPr sz="1600" u="none" cap="none" strike="noStrike"/>
                     </a:p>
@@ -14515,7 +14515,7 @@
                           <a:cs typeface="Calibri"/>
                           <a:sym typeface="Calibri"/>
                         </a:rPr>
-                        <a:t>{{bodyWidth}}</a:t>
+                        <a:t>{{רוחב_גוף}}</a:t>
                       </a:r>
                       <a:endParaRPr sz="1600" u="none" cap="none" strike="noStrike"/>
                     </a:p>
@@ -14659,7 +14659,7 @@
                           <a:cs typeface="Calibri"/>
                           <a:sym typeface="Calibri"/>
                         </a:rPr>
-                        <a:t>{{bodyHeight}}</a:t>
+                        <a:t>{{גובה_גוף}}</a:t>
                       </a:r>
                       <a:endParaRPr sz="1600" u="none" cap="none" strike="noStrike"/>
                     </a:p>
@@ -14803,7 +14803,7 @@
                           <a:cs typeface="Calibri"/>
                           <a:sym typeface="Calibri"/>
                         </a:rPr>
-                        <a:t>{{rosetteType}}</a:t>
+                        <a:t>{{סוג_רוזטה}}</a:t>
                       </a:r>
                       <a:endParaRPr sz="1600" u="none" cap="none" strike="noStrike"/>
                     </a:p>
@@ -14947,7 +14947,7 @@
                           <a:cs typeface="Calibri"/>
                           <a:sym typeface="Calibri"/>
                         </a:rPr>
-                        <a:t>{{importer}}</a:t>
+                        <a:t>{{יבואן}}</a:t>
                       </a:r>
                       <a:endParaRPr sz="1600" u="none" cap="none" strike="noStrike"/>
                     </a:p>
@@ -15282,7 +15282,7 @@
                 <a:cs typeface="Calibri"/>
                 <a:sym typeface="Calibri"/>
               </a:rPr>
-              <a:t>כתב כמויות תאורה | {{projectName}} {{projectName}}  </a:t>
+              <a:t>כתב כמויות תאורה | {{שם_פרויקט}} {{שם_פרויקט}}  </a:t>
             </a:r>
             <a:endParaRPr/>
           </a:p>
@@ -15335,7 +15335,7 @@
                 <a:cs typeface="Calibri"/>
                 <a:sym typeface="Calibri"/>
               </a:rPr>
-              <a:t>{{mark}}</a:t>
+              <a:t>{{סימון}}</a:t>
             </a:r>
             <a:endParaRPr/>
           </a:p>
@@ -15388,7 +15388,7 @@
                 <a:cs typeface="Calibri"/>
                 <a:sym typeface="Calibri"/>
               </a:rPr>
-              <a:t>{{productTitle}}</a:t>
+              <a:t>{{שם_מוצר}}</a:t>
             </a:r>
             <a:r>
               <a:rPr b="0" i="0" lang="iw-IL" sz="4400" u="none" cap="none" strike="noStrike">
@@ -15400,7 +15400,7 @@
                 <a:cs typeface="Calibri"/>
                 <a:sym typeface="Calibri"/>
               </a:rPr>
-              <a:t>{{manufacturer}}  |   דגם  ויצרן  </a:t>
+              <a:t>{{יצרן}}  |   דגם  ויצרן  </a:t>
             </a:r>
             <a:endParaRPr/>
           </a:p>
@@ -15453,7 +15453,7 @@
                 <a:cs typeface="Calibri"/>
                 <a:sym typeface="Calibri"/>
               </a:rPr>
-              <a:t>{{description}} </a:t>
+              <a:t>{{תיאור}} </a:t>
             </a:r>
             <a:endParaRPr/>
           </a:p>
@@ -15586,7 +15586,7 @@
                 <a:cs typeface="Calibri"/>
                 <a:sym typeface="Calibri"/>
               </a:rPr>
-              <a:t>{{lumens}}</a:t>
+              <a:t>{{לומן}}</a:t>
             </a:r>
             <a:endParaRPr/>
           </a:p>
@@ -15666,7 +15666,7 @@
                 <a:cs typeface="Calibri"/>
                 <a:sym typeface="Calibri"/>
               </a:rPr>
-              <a:t>{{colorTemp}}</a:t>
+              <a:t>{{טמפרטורת_צבע}}</a:t>
             </a:r>
             <a:endParaRPr/>
           </a:p>
@@ -15772,7 +15772,7 @@
                 <a:cs typeface="Calibri"/>
                 <a:sym typeface="Calibri"/>
               </a:rPr>
-              <a:t>{{watt}}</a:t>
+              <a:t>{{וואט}}</a:t>
             </a:r>
             <a:endParaRPr/>
           </a:p>
@@ -15852,7 +15852,7 @@
                 <a:cs typeface="Calibri"/>
                 <a:sym typeface="Calibri"/>
               </a:rPr>
-              <a:t>{{voltageCurrent}}</a:t>
+              <a:t>{{מתח_זרם}}</a:t>
             </a:r>
             <a:endParaRPr/>
           </a:p>
@@ -15932,7 +15932,7 @@
                 <a:cs typeface="Calibri"/>
                 <a:sym typeface="Calibri"/>
               </a:rPr>
-              <a:t>{{totalUnits}}</a:t>
+              <a:t>{{כמות_כוללת}}</a:t>
             </a:r>
             <a:endParaRPr/>
           </a:p>
@@ -16104,7 +16104,7 @@
                 <a:cs typeface="Calibri"/>
                 <a:sym typeface="Calibri"/>
               </a:rPr>
-              <a:t>{{sku}}</a:t>
+              <a:t>{{מקט}}</a:t>
             </a:r>
             <a:endParaRPr/>
           </a:p>
@@ -16157,7 +16157,7 @@
                 <a:cs typeface="Calibri"/>
                 <a:sym typeface="Calibri"/>
               </a:rPr>
-              <a:t>מקור אור/נורה: {{l</a:t>
+              <a:t>מקור אור/נורה: {{מקור_אור</a:t>
             </a:r>
             <a:r>
               <a:rPr b="0" i="0" lang="iw-IL" sz="3057" u="none" cap="none" strike="noStrike">
@@ -16169,7 +16169,7 @@
                 <a:cs typeface="Calibri"/>
                 <a:sym typeface="Calibri"/>
               </a:rPr>
-              <a:t>ightSource}} </a:t>
+              <a:t>}} </a:t>
             </a:r>
             <a:endParaRPr/>
           </a:p>
@@ -16329,7 +16329,7 @@
                 <a:cs typeface="Calibri"/>
                 <a:sym typeface="Calibri"/>
               </a:rPr>
-              <a:t>{{mountingInstructionsLabel}}</a:t>
+              <a:t>{{תווית_הוראות_התקנה}}</a:t>
             </a:r>
             <a:r>
               <a:rPr b="1" lang="iw-IL" sz="2400">
@@ -16373,7 +16373,7 @@
                   </a:extLst>
                 </a:hlinkClick>
               </a:rPr>
-              <a:t>{{mountingInstructionsUrl}} </a:t>
+              <a:t>{{קישור_הוראות_התקנה}} </a:t>
             </a:r>
             <a:endParaRPr b="1" sz="2400">
               <a:latin typeface="Calibri"/>

</xml_diff>